<commit_message>
Review Days 1 & 2, apply fixes
Day 1: repo setup -> homework (step-by-step in student pack); five events
trimmed to three told as stories; new 60s "where this leads" slide for early
motivation; trailer defaults to the recording on Day 1; run sheet rebuilt
with slack.

Day 2: enforce the one-analogy rule (kitchen only; drop the bank analogy);
move "why a bug becomes control" to right after program-vs-process, ~12 min;
cut the code/data/heap/stack slide (return-address idea now inline);
crash.py is instructor-only on the Linux projector.

Design doc: move "files" from Day 2 to Day 6; rewrite §11 as the production
process, adding the per-day expert+teacher review pass.

Co-Authored-By: Claude Sonnet 5 <noreply@anthropic.com>
Claude-Session: https://claude.ai/code/session_01KNTjuWocFXcyUV6RC52aCu
</commit_message>
<xml_diff>
--- a/lessons-v2/day01/day01.pptx
+++ b/lessons-v2/day01/day01.pptx
@@ -30,9 +30,10 @@
     <p:sldId id="278" r:id="rId24"/>
     <p:sldId id="279" r:id="rId25"/>
     <p:sldId id="280" r:id="rId26"/>
+    <p:sldId id="281" r:id="rId27"/>
   </p:sldIdLst>
   <p:notesMasterIdLst>
-    <p:notesMasterId r:id="rId27"/>
+    <p:notesMasterId r:id="rId28"/>
   </p:notesMasterIdLst>
   <p:sldSz cx="12192000" cy="6858000"/>
   <p:notesSz cx="6858000" cy="12192000"/>
@@ -526,17 +527,22 @@
           <a:p>
             <a:r>
               <a:rPr lang="en-US" dirty="0"/>
-              <a:t>RUN SHEET (90 min):
-00:00 Cold open / trailer demo
-00:05 What security actually is
-00:12 A short history of hackers &amp; crackers
-00:20 The CIA triad
-00:38 Ethics &amp; the law
-00:58 Pair activity
-01:10 How this course works
-01:22 Wrap + homework
-CUT FIRST IF SHORT: slide "Phreaking" detail, and drop the drill from 3 headlines to 2.
-Never cut: the authorization line, §43 vs §66, the repo setup.</a:t>
+              <a:t>RUN SHEET (~85 min planned, ~5 min slack):
+00:00 Trailer (play the recording) + journey framing   5
+00:05 What security actually is                          5
+00:10 What "hacking" is                                  3
+00:13 Where this leads (the field, the jobs)             3
+00:16 History: origins, phreaking, the word split        8
+00:24 Hat colours                                        4
+00:28 Three events, as stories                           7
+00:35 The CIA triad + drill                             13
+00:48 Ethics &amp; the law                                  15
+01:03 Pair activity                                     12
+01:15 How this course works (structure only)             6
+01:21 Wrap + homework                                    4
+CUT FIRST IF SHORT: phreaking detail; drill 3 -&gt; 2 headlines; the "rhythm" slide.
+NEVER CUT: the authorization line, IT Act §43 vs §66, the 3-line recap.
+NOTE: the course repo is set up as HOMEWORK, not in class. In class we only show the structure.</a:t>
             </a:r>
             <a:endParaRPr lang="en-US" dirty="0"/>
           </a:p>
@@ -579,6 +585,98 @@
 </file>
 
 <file path=ppt/notesSlides/notesSlide10.xml><?xml version="1.0" encoding="utf-8"?>
+<p:notes xmlns:a="http://schemas.openxmlformats.org/drawingml/2006/main" xmlns:r="http://schemas.openxmlformats.org/officeDocument/2006/relationships" xmlns:p="http://schemas.openxmlformats.org/presentationml/2006/main">
+  <p:cSld>
+    <p:spTree>
+      <p:nvGrpSpPr>
+        <p:cNvPr id="1" name=""/>
+        <p:cNvGrpSpPr/>
+        <p:nvPr/>
+      </p:nvGrpSpPr>
+      <p:grpSpPr>
+        <a:xfrm>
+          <a:off x="0" y="0"/>
+          <a:ext cx="0" cy="0"/>
+          <a:chOff x="0" y="0"/>
+          <a:chExt cx="0" cy="0"/>
+        </a:xfrm>
+      </p:grpSpPr>
+      <p:sp>
+        <p:nvSpPr>
+          <p:cNvPr id="2" name="Slide Image Placeholder 1"/>
+          <p:cNvSpPr>
+            <a:spLocks noGrp="1" noRot="1" noChangeAspect="1"/>
+          </p:cNvSpPr>
+          <p:nvPr>
+            <p:ph type="sldImg"/>
+          </p:nvPr>
+        </p:nvSpPr>
+        <p:spPr/>
+      </p:sp>
+      <p:sp>
+        <p:nvSpPr>
+          <p:cNvPr id="3" name="Notes Placeholder 2"/>
+          <p:cNvSpPr>
+            <a:spLocks noGrp="1"/>
+          </p:cNvSpPr>
+          <p:nvPr>
+            <p:ph type="body" idx="1"/>
+          </p:nvPr>
+        </p:nvSpPr>
+        <p:spPr/>
+        <p:txBody>
+          <a:bodyPr/>
+          <a:lstStyle/>
+          <a:p>
+            <a:r>
+              <a:rPr lang="en-US" dirty="0"/>
+              <a:t>Tell these as three short stories, ~2 min each. Mitnick is the one to land — it IS the point
+of today's ethics section.
+If a student asks about nation-state / Stuxnet, one line: "governments now do this at
+physical-damage scale — 2010, Iran's centrifuges." Don't put it on a slide.
+WannaCry ties forward to Day 11 (ransomware) and Day 2 (patching / the same bug = crash or RCE).</a:t>
+            </a:r>
+            <a:endParaRPr lang="en-US" dirty="0"/>
+          </a:p>
+        </p:txBody>
+      </p:sp>
+      <p:sp>
+        <p:nvSpPr>
+          <p:cNvPr id="4" name="Slide Number Placeholder 3"/>
+          <p:cNvSpPr>
+            <a:spLocks noGrp="1"/>
+          </p:cNvSpPr>
+          <p:nvPr>
+            <p:ph type="sldNum" sz="quarter" idx="10"/>
+          </p:nvPr>
+        </p:nvSpPr>
+        <p:spPr/>
+        <p:txBody>
+          <a:bodyPr/>
+          <a:lstStyle/>
+          <a:p>
+            <a:fld id="{F7021451-1387-4CA6-816F-3879F97B5CBC}" type="slidenum">
+              <a:rPr lang="en-US"/>
+              <a:t>10</a:t>
+            </a:fld>
+            <a:endParaRPr lang="en-US"/>
+          </a:p>
+        </p:txBody>
+      </p:sp>
+    </p:spTree>
+    <p:extLst>
+      <p:ext uri="{BB962C8B-B14F-4D97-AF65-F5344CB8AC3E}">
+        <p14:creationId xmlns:p14="http://schemas.microsoft.com/office/powerpoint/2010/main" val="1024086991"/>
+      </p:ext>
+    </p:extLst>
+  </p:cSld>
+  <p:clrMapOvr>
+    <a:masterClrMapping/>
+  </p:clrMapOvr>
+</p:notes>
+</file>
+
+<file path=ppt/notesSlides/notesSlide11.xml><?xml version="1.0" encoding="utf-8"?>
 <p:notes xmlns:a="http://schemas.openxmlformats.org/drawingml/2006/main" xmlns:r="http://schemas.openxmlformats.org/officeDocument/2006/relationships" xmlns:p="http://schemas.openxmlformats.org/presentationml/2006/main">
   <p:cSld>
     <p:spTree>
@@ -648,7 +746,7 @@
           <a:p>
             <a:fld id="{F7021451-1387-4CA6-816F-3879F97B5CBC}" type="slidenum">
               <a:rPr lang="en-US"/>
-              <a:t>10</a:t>
+              <a:t>11</a:t>
             </a:fld>
             <a:endParaRPr lang="en-US"/>
           </a:p>
@@ -667,7 +765,7 @@
 </p:notes>
 </file>
 
-<file path=ppt/notesSlides/notesSlide11.xml><?xml version="1.0" encoding="utf-8"?>
+<file path=ppt/notesSlides/notesSlide12.xml><?xml version="1.0" encoding="utf-8"?>
 <p:notes xmlns:a="http://schemas.openxmlformats.org/drawingml/2006/main" xmlns:r="http://schemas.openxmlformats.org/officeDocument/2006/relationships" xmlns:p="http://schemas.openxmlformats.org/presentationml/2006/main">
   <p:cSld>
     <p:spTree>
@@ -736,7 +834,7 @@
           <a:p>
             <a:fld id="{F7021451-1387-4CA6-816F-3879F97B5CBC}" type="slidenum">
               <a:rPr lang="en-US"/>
-              <a:t>11</a:t>
+              <a:t>12</a:t>
             </a:fld>
             <a:endParaRPr lang="en-US"/>
           </a:p>
@@ -755,7 +853,7 @@
 </p:notes>
 </file>
 
-<file path=ppt/notesSlides/notesSlide12.xml><?xml version="1.0" encoding="utf-8"?>
+<file path=ppt/notesSlides/notesSlide13.xml><?xml version="1.0" encoding="utf-8"?>
 <p:notes xmlns:a="http://schemas.openxmlformats.org/drawingml/2006/main" xmlns:r="http://schemas.openxmlformats.org/officeDocument/2006/relationships" xmlns:p="http://schemas.openxmlformats.org/presentationml/2006/main">
   <p:cSld>
     <p:spTree>
@@ -825,7 +923,7 @@
           <a:p>
             <a:fld id="{F7021451-1387-4CA6-816F-3879F97B5CBC}" type="slidenum">
               <a:rPr lang="en-US"/>
-              <a:t>12</a:t>
+              <a:t>13</a:t>
             </a:fld>
             <a:endParaRPr lang="en-US"/>
           </a:p>
@@ -844,7 +942,7 @@
 </p:notes>
 </file>
 
-<file path=ppt/notesSlides/notesSlide13.xml><?xml version="1.0" encoding="utf-8"?>
+<file path=ppt/notesSlides/notesSlide14.xml><?xml version="1.0" encoding="utf-8"?>
 <p:notes xmlns:a="http://schemas.openxmlformats.org/drawingml/2006/main" xmlns:r="http://schemas.openxmlformats.org/officeDocument/2006/relationships" xmlns:p="http://schemas.openxmlformats.org/presentationml/2006/main">
   <p:cSld>
     <p:spTree>
@@ -914,7 +1012,7 @@
           <a:p>
             <a:fld id="{F7021451-1387-4CA6-816F-3879F97B5CBC}" type="slidenum">
               <a:rPr lang="en-US"/>
-              <a:t>13</a:t>
+              <a:t>14</a:t>
             </a:fld>
             <a:endParaRPr lang="en-US"/>
           </a:p>
@@ -933,7 +1031,7 @@
 </p:notes>
 </file>
 
-<file path=ppt/notesSlides/notesSlide14.xml><?xml version="1.0" encoding="utf-8"?>
+<file path=ppt/notesSlides/notesSlide15.xml><?xml version="1.0" encoding="utf-8"?>
 <p:notes xmlns:a="http://schemas.openxmlformats.org/drawingml/2006/main" xmlns:r="http://schemas.openxmlformats.org/officeDocument/2006/relationships" xmlns:p="http://schemas.openxmlformats.org/presentationml/2006/main">
   <p:cSld>
     <p:spTree>
@@ -1004,7 +1102,7 @@
           <a:p>
             <a:fld id="{F7021451-1387-4CA6-816F-3879F97B5CBC}" type="slidenum">
               <a:rPr lang="en-US"/>
-              <a:t>14</a:t>
+              <a:t>15</a:t>
             </a:fld>
             <a:endParaRPr lang="en-US"/>
           </a:p>
@@ -1023,7 +1121,7 @@
 </p:notes>
 </file>
 
-<file path=ppt/notesSlides/notesSlide15.xml><?xml version="1.0" encoding="utf-8"?>
+<file path=ppt/notesSlides/notesSlide16.xml><?xml version="1.0" encoding="utf-8"?>
 <p:notes xmlns:a="http://schemas.openxmlformats.org/drawingml/2006/main" xmlns:r="http://schemas.openxmlformats.org/officeDocument/2006/relationships" xmlns:p="http://schemas.openxmlformats.org/presentationml/2006/main">
   <p:cSld>
     <p:spTree>
@@ -1092,7 +1190,7 @@
           <a:p>
             <a:fld id="{F7021451-1387-4CA6-816F-3879F97B5CBC}" type="slidenum">
               <a:rPr lang="en-US"/>
-              <a:t>15</a:t>
+              <a:t>16</a:t>
             </a:fld>
             <a:endParaRPr lang="en-US"/>
           </a:p>
@@ -1111,7 +1209,7 @@
 </p:notes>
 </file>
 
-<file path=ppt/notesSlides/notesSlide16.xml><?xml version="1.0" encoding="utf-8"?>
+<file path=ppt/notesSlides/notesSlide17.xml><?xml version="1.0" encoding="utf-8"?>
 <p:notes xmlns:a="http://schemas.openxmlformats.org/drawingml/2006/main" xmlns:r="http://schemas.openxmlformats.org/officeDocument/2006/relationships" xmlns:p="http://schemas.openxmlformats.org/presentationml/2006/main">
   <p:cSld>
     <p:spTree>
@@ -1181,7 +1279,7 @@
           <a:p>
             <a:fld id="{F7021451-1387-4CA6-816F-3879F97B5CBC}" type="slidenum">
               <a:rPr lang="en-US"/>
-              <a:t>16</a:t>
+              <a:t>17</a:t>
             </a:fld>
             <a:endParaRPr lang="en-US"/>
           </a:p>
@@ -1200,7 +1298,7 @@
 </p:notes>
 </file>
 
-<file path=ppt/notesSlides/notesSlide17.xml><?xml version="1.0" encoding="utf-8"?>
+<file path=ppt/notesSlides/notesSlide18.xml><?xml version="1.0" encoding="utf-8"?>
 <p:notes xmlns:a="http://schemas.openxmlformats.org/drawingml/2006/main" xmlns:r="http://schemas.openxmlformats.org/officeDocument/2006/relationships" xmlns:p="http://schemas.openxmlformats.org/presentationml/2006/main">
   <p:cSld>
     <p:spTree>
@@ -1271,7 +1369,7 @@
           <a:p>
             <a:fld id="{F7021451-1387-4CA6-816F-3879F97B5CBC}" type="slidenum">
               <a:rPr lang="en-US"/>
-              <a:t>17</a:t>
+              <a:t>18</a:t>
             </a:fld>
             <a:endParaRPr lang="en-US"/>
           </a:p>
@@ -1290,7 +1388,7 @@
 </p:notes>
 </file>
 
-<file path=ppt/notesSlides/notesSlide18.xml><?xml version="1.0" encoding="utf-8"?>
+<file path=ppt/notesSlides/notesSlide19.xml><?xml version="1.0" encoding="utf-8"?>
 <p:notes xmlns:a="http://schemas.openxmlformats.org/drawingml/2006/main" xmlns:r="http://schemas.openxmlformats.org/officeDocument/2006/relationships" xmlns:p="http://schemas.openxmlformats.org/presentationml/2006/main">
   <p:cSld>
     <p:spTree>
@@ -1361,7 +1459,7 @@
           <a:p>
             <a:fld id="{F7021451-1387-4CA6-816F-3879F97B5CBC}" type="slidenum">
               <a:rPr lang="en-US"/>
-              <a:t>18</a:t>
+              <a:t>19</a:t>
             </a:fld>
             <a:endParaRPr lang="en-US"/>
           </a:p>
@@ -1380,7 +1478,102 @@
 </p:notes>
 </file>
 
-<file path=ppt/notesSlides/notesSlide19.xml><?xml version="1.0" encoding="utf-8"?>
+<file path=ppt/notesSlides/notesSlide2.xml><?xml version="1.0" encoding="utf-8"?>
+<p:notes xmlns:a="http://schemas.openxmlformats.org/drawingml/2006/main" xmlns:r="http://schemas.openxmlformats.org/officeDocument/2006/relationships" xmlns:p="http://schemas.openxmlformats.org/presentationml/2006/main">
+  <p:cSld>
+    <p:spTree>
+      <p:nvGrpSpPr>
+        <p:cNvPr id="1" name=""/>
+        <p:cNvGrpSpPr/>
+        <p:nvPr/>
+      </p:nvGrpSpPr>
+      <p:grpSpPr>
+        <a:xfrm>
+          <a:off x="0" y="0"/>
+          <a:ext cx="0" cy="0"/>
+          <a:chOff x="0" y="0"/>
+          <a:chExt cx="0" cy="0"/>
+        </a:xfrm>
+      </p:grpSpPr>
+      <p:sp>
+        <p:nvSpPr>
+          <p:cNvPr id="2" name="Slide Image Placeholder 1"/>
+          <p:cNvSpPr>
+            <a:spLocks noGrp="1" noRot="1" noChangeAspect="1"/>
+          </p:cNvSpPr>
+          <p:nvPr>
+            <p:ph type="sldImg"/>
+          </p:nvPr>
+        </p:nvSpPr>
+        <p:spPr/>
+      </p:sp>
+      <p:sp>
+        <p:nvSpPr>
+          <p:cNvPr id="3" name="Notes Placeholder 2"/>
+          <p:cNvSpPr>
+            <a:spLocks noGrp="1"/>
+          </p:cNvSpPr>
+          <p:nvPr>
+            <p:ph type="body" idx="1"/>
+          </p:nvPr>
+        </p:nvSpPr>
+        <p:spPr/>
+        <p:txBody>
+          <a:bodyPr/>
+          <a:lstStyle/>
+          <a:p>
+            <a:r>
+              <a:rPr lang="en-US" dirty="0"/>
+              <a:t>TRAILER. On Day 1, DEFAULT TO THE RECORDING (assets/trailer-demo.mp4, 60s) — first impression,
+don't gamble on a live capture. Only run it live if you've done the pre-flight and you're
+confident (runbook in teacher-notes.md).
+Narrate over it: instructor logs into a plain-HTTP page; a second terminal (tcpdump) shows the
+username + password in cleartext.
+SAY: "I never touched their computer. I watched the wire. That's the whole field in one move.
+In 20 days you do this yourself — and you'll know exactly why HTTPS makes it stop working."
+Do NOT explain how. That's Day 4.</a:t>
+            </a:r>
+            <a:endParaRPr lang="en-US" dirty="0"/>
+          </a:p>
+        </p:txBody>
+      </p:sp>
+      <p:sp>
+        <p:nvSpPr>
+          <p:cNvPr id="4" name="Slide Number Placeholder 3"/>
+          <p:cNvSpPr>
+            <a:spLocks noGrp="1"/>
+          </p:cNvSpPr>
+          <p:nvPr>
+            <p:ph type="sldNum" sz="quarter" idx="10"/>
+          </p:nvPr>
+        </p:nvSpPr>
+        <p:spPr/>
+        <p:txBody>
+          <a:bodyPr/>
+          <a:lstStyle/>
+          <a:p>
+            <a:fld id="{F7021451-1387-4CA6-816F-3879F97B5CBC}" type="slidenum">
+              <a:rPr lang="en-US"/>
+              <a:t>2</a:t>
+            </a:fld>
+            <a:endParaRPr lang="en-US"/>
+          </a:p>
+        </p:txBody>
+      </p:sp>
+    </p:spTree>
+    <p:extLst>
+      <p:ext uri="{BB962C8B-B14F-4D97-AF65-F5344CB8AC3E}">
+        <p14:creationId xmlns:p14="http://schemas.microsoft.com/office/powerpoint/2010/main" val="1024086991"/>
+      </p:ext>
+    </p:extLst>
+  </p:cSld>
+  <p:clrMapOvr>
+    <a:masterClrMapping/>
+  </p:clrMapOvr>
+</p:notes>
+</file>
+
+<file path=ppt/notesSlides/notesSlide20.xml><?xml version="1.0" encoding="utf-8"?>
 <p:notes xmlns:a="http://schemas.openxmlformats.org/drawingml/2006/main" xmlns:r="http://schemas.openxmlformats.org/officeDocument/2006/relationships" xmlns:p="http://schemas.openxmlformats.org/presentationml/2006/main">
   <p:cSld>
     <p:spTree>
@@ -1451,7 +1644,7 @@
           <a:p>
             <a:fld id="{F7021451-1387-4CA6-816F-3879F97B5CBC}" type="slidenum">
               <a:rPr lang="en-US"/>
-              <a:t>19</a:t>
+              <a:t>20</a:t>
             </a:fld>
             <a:endParaRPr lang="en-US"/>
           </a:p>
@@ -1470,102 +1663,7 @@
 </p:notes>
 </file>
 
-<file path=ppt/notesSlides/notesSlide2.xml><?xml version="1.0" encoding="utf-8"?>
-<p:notes xmlns:a="http://schemas.openxmlformats.org/drawingml/2006/main" xmlns:r="http://schemas.openxmlformats.org/officeDocument/2006/relationships" xmlns:p="http://schemas.openxmlformats.org/presentationml/2006/main">
-  <p:cSld>
-    <p:spTree>
-      <p:nvGrpSpPr>
-        <p:cNvPr id="1" name=""/>
-        <p:cNvGrpSpPr/>
-        <p:nvPr/>
-      </p:nvGrpSpPr>
-      <p:grpSpPr>
-        <a:xfrm>
-          <a:off x="0" y="0"/>
-          <a:ext cx="0" cy="0"/>
-          <a:chOff x="0" y="0"/>
-          <a:chExt cx="0" cy="0"/>
-        </a:xfrm>
-      </p:grpSpPr>
-      <p:sp>
-        <p:nvSpPr>
-          <p:cNvPr id="2" name="Slide Image Placeholder 1"/>
-          <p:cNvSpPr>
-            <a:spLocks noGrp="1" noRot="1" noChangeAspect="1"/>
-          </p:cNvSpPr>
-          <p:nvPr>
-            <p:ph type="sldImg"/>
-          </p:nvPr>
-        </p:nvSpPr>
-        <p:spPr/>
-      </p:sp>
-      <p:sp>
-        <p:nvSpPr>
-          <p:cNvPr id="3" name="Notes Placeholder 2"/>
-          <p:cNvSpPr>
-            <a:spLocks noGrp="1"/>
-          </p:cNvSpPr>
-          <p:nvPr>
-            <p:ph type="body" idx="1"/>
-          </p:nvPr>
-        </p:nvSpPr>
-        <p:spPr/>
-        <p:txBody>
-          <a:bodyPr/>
-          <a:lstStyle/>
-          <a:p>
-            <a:r>
-              <a:rPr lang="en-US" dirty="0"/>
-              <a:t>TRAILER DEMO. Do it live if the pre-flight passed; otherwise play assets/trailer-demo.mp4.
-Setup: instructor laptop on class network. Terminal 1: sudo tcpdump -i &lt;iface&gt; -A 'tcp port 80'
-Terminal 2 / browser: log into http://&lt;target-server&gt;/login with a fake user "student / hunter2".
-Switch to Terminal 1, scroll to the POST, point at the cleartext username + password.
-SAY: "I never touched their computer. I watched the wire. That is the whole field in one move.
-In 20 days you will do this yourself — and you'll know exactly why HTTPS makes it stop working."
-Do NOT explain how yet. That's Day 4.
-FALLBACK: assets/trailer-demo.mp4 (60s). Narrate over it the same way.</a:t>
-            </a:r>
-            <a:endParaRPr lang="en-US" dirty="0"/>
-          </a:p>
-        </p:txBody>
-      </p:sp>
-      <p:sp>
-        <p:nvSpPr>
-          <p:cNvPr id="4" name="Slide Number Placeholder 3"/>
-          <p:cNvSpPr>
-            <a:spLocks noGrp="1"/>
-          </p:cNvSpPr>
-          <p:nvPr>
-            <p:ph type="sldNum" sz="quarter" idx="10"/>
-          </p:nvPr>
-        </p:nvSpPr>
-        <p:spPr/>
-        <p:txBody>
-          <a:bodyPr/>
-          <a:lstStyle/>
-          <a:p>
-            <a:fld id="{F7021451-1387-4CA6-816F-3879F97B5CBC}" type="slidenum">
-              <a:rPr lang="en-US"/>
-              <a:t>2</a:t>
-            </a:fld>
-            <a:endParaRPr lang="en-US"/>
-          </a:p>
-        </p:txBody>
-      </p:sp>
-    </p:spTree>
-    <p:extLst>
-      <p:ext uri="{BB962C8B-B14F-4D97-AF65-F5344CB8AC3E}">
-        <p14:creationId xmlns:p14="http://schemas.microsoft.com/office/powerpoint/2010/main" val="1024086991"/>
-      </p:ext>
-    </p:extLst>
-  </p:cSld>
-  <p:clrMapOvr>
-    <a:masterClrMapping/>
-  </p:clrMapOvr>
-</p:notes>
-</file>
-
-<file path=ppt/notesSlides/notesSlide20.xml><?xml version="1.0" encoding="utf-8"?>
+<file path=ppt/notesSlides/notesSlide21.xml><?xml version="1.0" encoding="utf-8"?>
 <p:notes xmlns:a="http://schemas.openxmlformats.org/drawingml/2006/main" xmlns:r="http://schemas.openxmlformats.org/officeDocument/2006/relationships" xmlns:p="http://schemas.openxmlformats.org/presentationml/2006/main">
   <p:cSld>
     <p:spTree>
@@ -1636,7 +1734,7 @@
           <a:p>
             <a:fld id="{F7021451-1387-4CA6-816F-3879F97B5CBC}" type="slidenum">
               <a:rPr lang="en-US"/>
-              <a:t>20</a:t>
+              <a:t>21</a:t>
             </a:fld>
             <a:endParaRPr lang="en-US"/>
           </a:p>
@@ -1655,7 +1753,7 @@
 </p:notes>
 </file>
 
-<file path=ppt/notesSlides/notesSlide21.xml><?xml version="1.0" encoding="utf-8"?>
+<file path=ppt/notesSlides/notesSlide22.xml><?xml version="1.0" encoding="utf-8"?>
 <p:notes xmlns:a="http://schemas.openxmlformats.org/drawingml/2006/main" xmlns:r="http://schemas.openxmlformats.org/officeDocument/2006/relationships" xmlns:p="http://schemas.openxmlformats.org/presentationml/2006/main">
   <p:cSld>
     <p:spTree>
@@ -1702,8 +1800,8 @@
             <a:r>
               <a:rPr lang="en-US" dirty="0"/>
               <a:t>Show them the whole arc so nobody feels lost in the "boring plumbing" of weeks 1-2.
-Tell them explicitly: "the first two weeks feel less like "hacking" — that's on purpose.
-You cannot attack or defend a thing you don't understand."</a:t>
+Tell them explicitly: "the first two weeks feel less like 'hacking' — that's on purpose.
+You cannot attack or defend a thing you don't understand." Callback to the "where this leads" slide.</a:t>
             </a:r>
             <a:endParaRPr lang="en-US" dirty="0"/>
           </a:p>
@@ -1726,7 +1824,7 @@
           <a:p>
             <a:fld id="{F7021451-1387-4CA6-816F-3879F97B5CBC}" type="slidenum">
               <a:rPr lang="en-US"/>
-              <a:t>21</a:t>
+              <a:t>22</a:t>
             </a:fld>
             <a:endParaRPr lang="en-US"/>
           </a:p>
@@ -1745,7 +1843,7 @@
 </p:notes>
 </file>
 
-<file path=ppt/notesSlides/notesSlide22.xml><?xml version="1.0" encoding="utf-8"?>
+<file path=ppt/notesSlides/notesSlide23.xml><?xml version="1.0" encoding="utf-8"?>
 <p:notes xmlns:a="http://schemas.openxmlformats.org/drawingml/2006/main" xmlns:r="http://schemas.openxmlformats.org/officeDocument/2006/relationships" xmlns:p="http://schemas.openxmlformats.org/presentationml/2006/main">
   <p:cSld>
     <p:spTree>
@@ -1791,7 +1889,8 @@
           <a:p>
             <a:r>
               <a:rPr lang="en-US" dirty="0"/>
-              <a:t>Set up the repo live now (lab-guide steps in student pack). GitHub or GitLab account, one repo, a README.
+              <a:t>Show the target repo structure on screen for ~90 seconds (README.md, day01/, day02/, ...).
+Do NOT do account creation in class — it's tonight's homework (step-by-step in the student pack).
 This repo is graded lightly all course and heavily at the capstone. It's also what they show employers.</a:t>
             </a:r>
             <a:endParaRPr lang="en-US" dirty="0"/>
@@ -1815,7 +1914,7 @@
           <a:p>
             <a:fld id="{F7021451-1387-4CA6-816F-3879F97B5CBC}" type="slidenum">
               <a:rPr lang="en-US"/>
-              <a:t>22</a:t>
+              <a:t>23</a:t>
             </a:fld>
             <a:endParaRPr lang="en-US"/>
           </a:p>
@@ -1834,7 +1933,7 @@
 </p:notes>
 </file>
 
-<file path=ppt/notesSlides/notesSlide23.xml><?xml version="1.0" encoding="utf-8"?>
+<file path=ppt/notesSlides/notesSlide24.xml><?xml version="1.0" encoding="utf-8"?>
 <p:notes xmlns:a="http://schemas.openxmlformats.org/drawingml/2006/main" xmlns:r="http://schemas.openxmlformats.org/officeDocument/2006/relationships" xmlns:p="http://schemas.openxmlformats.org/presentationml/2006/main">
   <p:cSld>
     <p:spTree>
@@ -1903,7 +2002,7 @@
           <a:p>
             <a:fld id="{F7021451-1387-4CA6-816F-3879F97B5CBC}" type="slidenum">
               <a:rPr lang="en-US"/>
-              <a:t>23</a:t>
+              <a:t>24</a:t>
             </a:fld>
             <a:endParaRPr lang="en-US"/>
           </a:p>
@@ -1922,7 +2021,7 @@
 </p:notes>
 </file>
 
-<file path=ppt/notesSlides/notesSlide24.xml><?xml version="1.0" encoding="utf-8"?>
+<file path=ppt/notesSlides/notesSlide25.xml><?xml version="1.0" encoding="utf-8"?>
 <p:notes xmlns:a="http://schemas.openxmlformats.org/drawingml/2006/main" xmlns:r="http://schemas.openxmlformats.org/officeDocument/2006/relationships" xmlns:p="http://schemas.openxmlformats.org/presentationml/2006/main">
   <p:cSld>
     <p:spTree>
@@ -1991,7 +2090,7 @@
           <a:p>
             <a:fld id="{F7021451-1387-4CA6-816F-3879F97B5CBC}" type="slidenum">
               <a:rPr lang="en-US"/>
-              <a:t>24</a:t>
+              <a:t>25</a:t>
             </a:fld>
             <a:endParaRPr lang="en-US"/>
           </a:p>
@@ -2010,7 +2109,7 @@
 </p:notes>
 </file>
 
-<file path=ppt/notesSlides/notesSlide25.xml><?xml version="1.0" encoding="utf-8"?>
+<file path=ppt/notesSlides/notesSlide26.xml><?xml version="1.0" encoding="utf-8"?>
 <p:notes xmlns:a="http://schemas.openxmlformats.org/drawingml/2006/main" xmlns:r="http://schemas.openxmlformats.org/officeDocument/2006/relationships" xmlns:p="http://schemas.openxmlformats.org/presentationml/2006/main">
   <p:cSld>
     <p:spTree>
@@ -2080,7 +2179,7 @@
           <a:p>
             <a:fld id="{F7021451-1387-4CA6-816F-3879F97B5CBC}" type="slidenum">
               <a:rPr lang="en-US"/>
-              <a:t>25</a:t>
+              <a:t>26</a:t>
             </a:fld>
             <a:endParaRPr lang="en-US"/>
           </a:p>
@@ -2238,7 +2337,7 @@
               <a:rPr lang="en-US" dirty="0"/>
               <a:t>Reassure the room: you do not need to be a prodigy. You need to be the person who reads the manual,
 takes the thing apart, and asks "what happens if I do the unexpected thing?"
-The word "hacking" in this room = the skill. Whether it's a crime depends on AUTHORIZATION — next 40 min.</a:t>
+The word "hacking" in this room = the skill. Whether it's a crime depends on AUTHORIZATION — later today.</a:t>
             </a:r>
             <a:endParaRPr lang="en-US" dirty="0"/>
           </a:p>
@@ -2281,6 +2380,97 @@
 </file>
 
 <file path=ppt/notesSlides/notesSlide5.xml><?xml version="1.0" encoding="utf-8"?>
+<p:notes xmlns:a="http://schemas.openxmlformats.org/drawingml/2006/main" xmlns:r="http://schemas.openxmlformats.org/officeDocument/2006/relationships" xmlns:p="http://schemas.openxmlformats.org/presentationml/2006/main">
+  <p:cSld>
+    <p:spTree>
+      <p:nvGrpSpPr>
+        <p:cNvPr id="1" name=""/>
+        <p:cNvGrpSpPr/>
+        <p:nvPr/>
+      </p:nvGrpSpPr>
+      <p:grpSpPr>
+        <a:xfrm>
+          <a:off x="0" y="0"/>
+          <a:ext cx="0" cy="0"/>
+          <a:chOff x="0" y="0"/>
+          <a:chExt cx="0" cy="0"/>
+        </a:xfrm>
+      </p:grpSpPr>
+      <p:sp>
+        <p:nvSpPr>
+          <p:cNvPr id="2" name="Slide Image Placeholder 1"/>
+          <p:cNvSpPr>
+            <a:spLocks noGrp="1" noRot="1" noChangeAspect="1"/>
+          </p:cNvSpPr>
+          <p:nvPr>
+            <p:ph type="sldImg"/>
+          </p:nvPr>
+        </p:nvSpPr>
+        <p:spPr/>
+      </p:sp>
+      <p:sp>
+        <p:nvSpPr>
+          <p:cNvPr id="3" name="Notes Placeholder 2"/>
+          <p:cNvSpPr>
+            <a:spLocks noGrp="1"/>
+          </p:cNvSpPr>
+          <p:nvPr>
+            <p:ph type="body" idx="1"/>
+          </p:nvPr>
+        </p:nvSpPr>
+        <p:spPr/>
+        <p:txBody>
+          <a:bodyPr/>
+          <a:lstStyle/>
+          <a:p>
+            <a:r>
+              <a:rPr lang="en-US" dirty="0"/>
+              <a:t>60 seconds. Purpose: the room is full of students who signed up to "hack" — tell them there's
+a job at the end and the course is built to get them to a real next step.
+Don't sell hard. Just plant: "by Day 20 you'll know which of these lights you up."
+Full careers treatment is Day 20.</a:t>
+            </a:r>
+            <a:endParaRPr lang="en-US" dirty="0"/>
+          </a:p>
+        </p:txBody>
+      </p:sp>
+      <p:sp>
+        <p:nvSpPr>
+          <p:cNvPr id="4" name="Slide Number Placeholder 3"/>
+          <p:cNvSpPr>
+            <a:spLocks noGrp="1"/>
+          </p:cNvSpPr>
+          <p:nvPr>
+            <p:ph type="sldNum" sz="quarter" idx="10"/>
+          </p:nvPr>
+        </p:nvSpPr>
+        <p:spPr/>
+        <p:txBody>
+          <a:bodyPr/>
+          <a:lstStyle/>
+          <a:p>
+            <a:fld id="{F7021451-1387-4CA6-816F-3879F97B5CBC}" type="slidenum">
+              <a:rPr lang="en-US"/>
+              <a:t>5</a:t>
+            </a:fld>
+            <a:endParaRPr lang="en-US"/>
+          </a:p>
+        </p:txBody>
+      </p:sp>
+    </p:spTree>
+    <p:extLst>
+      <p:ext uri="{BB962C8B-B14F-4D97-AF65-F5344CB8AC3E}">
+        <p14:creationId xmlns:p14="http://schemas.microsoft.com/office/powerpoint/2010/main" val="1024086991"/>
+      </p:ext>
+    </p:extLst>
+  </p:cSld>
+  <p:clrMapOvr>
+    <a:masterClrMapping/>
+  </p:clrMapOvr>
+</p:notes>
+</file>
+
+<file path=ppt/notesSlides/notesSlide6.xml><?xml version="1.0" encoding="utf-8"?>
 <p:notes xmlns:a="http://schemas.openxmlformats.org/drawingml/2006/main" xmlns:r="http://schemas.openxmlformats.org/officeDocument/2006/relationships" xmlns:p="http://schemas.openxmlformats.org/presentationml/2006/main">
   <p:cSld>
     <p:spTree>
@@ -2352,7 +2542,7 @@
           <a:p>
             <a:fld id="{F7021451-1387-4CA6-816F-3879F97B5CBC}" type="slidenum">
               <a:rPr lang="en-US"/>
-              <a:t>5</a:t>
+              <a:t>6</a:t>
             </a:fld>
             <a:endParaRPr lang="en-US"/>
           </a:p>
@@ -2371,7 +2561,7 @@
 </p:notes>
 </file>
 
-<file path=ppt/notesSlides/notesSlide6.xml><?xml version="1.0" encoding="utf-8"?>
+<file path=ppt/notesSlides/notesSlide7.xml><?xml version="1.0" encoding="utf-8"?>
 <p:notes xmlns:a="http://schemas.openxmlformats.org/drawingml/2006/main" xmlns:r="http://schemas.openxmlformats.org/officeDocument/2006/relationships" xmlns:p="http://schemas.openxmlformats.org/presentationml/2006/main">
   <p:cSld>
     <p:spTree>
@@ -2442,7 +2632,7 @@
           <a:p>
             <a:fld id="{F7021451-1387-4CA6-816F-3879F97B5CBC}" type="slidenum">
               <a:rPr lang="en-US"/>
-              <a:t>6</a:t>
+              <a:t>7</a:t>
             </a:fld>
             <a:endParaRPr lang="en-US"/>
           </a:p>
@@ -2461,7 +2651,7 @@
 </p:notes>
 </file>
 
-<file path=ppt/notesSlides/notesSlide7.xml><?xml version="1.0" encoding="utf-8"?>
+<file path=ppt/notesSlides/notesSlide8.xml><?xml version="1.0" encoding="utf-8"?>
 <p:notes xmlns:a="http://schemas.openxmlformats.org/drawingml/2006/main" xmlns:r="http://schemas.openxmlformats.org/officeDocument/2006/relationships" xmlns:p="http://schemas.openxmlformats.org/presentationml/2006/main">
   <p:cSld>
     <p:spTree>
@@ -2532,7 +2722,7 @@
           <a:p>
             <a:fld id="{F7021451-1387-4CA6-816F-3879F97B5CBC}" type="slidenum">
               <a:rPr lang="en-US"/>
-              <a:t>7</a:t>
+              <a:t>8</a:t>
             </a:fld>
             <a:endParaRPr lang="en-US"/>
           </a:p>
@@ -2551,7 +2741,7 @@
 </p:notes>
 </file>
 
-<file path=ppt/notesSlides/notesSlide8.xml><?xml version="1.0" encoding="utf-8"?>
+<file path=ppt/notesSlides/notesSlide9.xml><?xml version="1.0" encoding="utf-8"?>
 <p:notes xmlns:a="http://schemas.openxmlformats.org/drawingml/2006/main" xmlns:r="http://schemas.openxmlformats.org/officeDocument/2006/relationships" xmlns:p="http://schemas.openxmlformats.org/presentationml/2006/main">
   <p:cSld>
     <p:spTree>
@@ -2600,97 +2790,6 @@
               <a:t>HAMMER the grey-hat line. Students will be tempted to "just test" the college portal or a friend's site.
 "Not malicious" is not a legal defence under the IT Act (next slides).
 White hat = pentester with a contract, bug-bounty participant within program rules, your own lab.</a:t>
-            </a:r>
-            <a:endParaRPr lang="en-US" dirty="0"/>
-          </a:p>
-        </p:txBody>
-      </p:sp>
-      <p:sp>
-        <p:nvSpPr>
-          <p:cNvPr id="4" name="Slide Number Placeholder 3"/>
-          <p:cNvSpPr>
-            <a:spLocks noGrp="1"/>
-          </p:cNvSpPr>
-          <p:nvPr>
-            <p:ph type="sldNum" sz="quarter" idx="10"/>
-          </p:nvPr>
-        </p:nvSpPr>
-        <p:spPr/>
-        <p:txBody>
-          <a:bodyPr/>
-          <a:lstStyle/>
-          <a:p>
-            <a:fld id="{F7021451-1387-4CA6-816F-3879F97B5CBC}" type="slidenum">
-              <a:rPr lang="en-US"/>
-              <a:t>8</a:t>
-            </a:fld>
-            <a:endParaRPr lang="en-US"/>
-          </a:p>
-        </p:txBody>
-      </p:sp>
-    </p:spTree>
-    <p:extLst>
-      <p:ext uri="{BB962C8B-B14F-4D97-AF65-F5344CB8AC3E}">
-        <p14:creationId xmlns:p14="http://schemas.microsoft.com/office/powerpoint/2010/main" val="1024086991"/>
-      </p:ext>
-    </p:extLst>
-  </p:cSld>
-  <p:clrMapOvr>
-    <a:masterClrMapping/>
-  </p:clrMapOvr>
-</p:notes>
-</file>
-
-<file path=ppt/notesSlides/notesSlide9.xml><?xml version="1.0" encoding="utf-8"?>
-<p:notes xmlns:a="http://schemas.openxmlformats.org/drawingml/2006/main" xmlns:r="http://schemas.openxmlformats.org/officeDocument/2006/relationships" xmlns:p="http://schemas.openxmlformats.org/presentationml/2006/main">
-  <p:cSld>
-    <p:spTree>
-      <p:nvGrpSpPr>
-        <p:cNvPr id="1" name=""/>
-        <p:cNvGrpSpPr/>
-        <p:nvPr/>
-      </p:nvGrpSpPr>
-      <p:grpSpPr>
-        <a:xfrm>
-          <a:off x="0" y="0"/>
-          <a:ext cx="0" cy="0"/>
-          <a:chOff x="0" y="0"/>
-          <a:chExt cx="0" cy="0"/>
-        </a:xfrm>
-      </p:grpSpPr>
-      <p:sp>
-        <p:nvSpPr>
-          <p:cNvPr id="2" name="Slide Image Placeholder 1"/>
-          <p:cNvSpPr>
-            <a:spLocks noGrp="1" noRot="1" noChangeAspect="1"/>
-          </p:cNvSpPr>
-          <p:nvPr>
-            <p:ph type="sldImg"/>
-          </p:nvPr>
-        </p:nvSpPr>
-        <p:spPr/>
-      </p:sp>
-      <p:sp>
-        <p:nvSpPr>
-          <p:cNvPr id="3" name="Notes Placeholder 2"/>
-          <p:cNvSpPr>
-            <a:spLocks noGrp="1"/>
-          </p:cNvSpPr>
-          <p:nvPr>
-            <p:ph type="body" idx="1"/>
-          </p:nvPr>
-        </p:nvSpPr>
-        <p:spPr/>
-        <p:txBody>
-          <a:bodyPr/>
-          <a:lstStyle/>
-          <a:p>
-            <a:r>
-              <a:rPr lang="en-US" dirty="0"/>
-              <a:t>The Mitnick arc is the one to dwell on: the exact same skills, on the wrong side of authorization = prison;
-on the right side = a career. That is the entire point of today.
-Stuxnet: you don't need details, just "governments do this now, at physical-damage scale."
-WannaCry: exploited a stolen NSA tool (EternalBlue); hit the UK NHS hard. Ties to Day 11 (ransomware).</a:t>
             </a:r>
             <a:endParaRPr lang="en-US" dirty="0"/>
           </a:p>
@@ -3705,6 +3804,45 @@
 <file path=ppt/slides/slide25.xml><?xml version="1.0" encoding="utf-8"?>
 <p:sld xmlns:a="http://schemas.openxmlformats.org/drawingml/2006/main" xmlns:r="http://schemas.openxmlformats.org/officeDocument/2006/relationships" xmlns:p="http://schemas.openxmlformats.org/presentationml/2006/main">
   <p:cSld name="Slide 25">
+    <p:bg>
+      <p:bgPr>
+        <a:blipFill dpi="0" rotWithShape="1">
+          <a:blip r:embed="rId1">
+            <a:lum/>
+          </a:blip>
+          <a:srcRect/>
+          <a:stretch>
+            <a:fillRect/>
+          </a:stretch>
+        </a:blipFill>
+        <a:effectLst/>
+      </p:bgPr>
+    </p:bg>
+    <p:spTree>
+      <p:nvGrpSpPr>
+        <p:cNvPr id="1" name=""/>
+        <p:cNvGrpSpPr/>
+        <p:nvPr/>
+      </p:nvGrpSpPr>
+      <p:grpSpPr>
+        <a:xfrm>
+          <a:off x="0" y="0"/>
+          <a:ext cx="0" cy="0"/>
+          <a:chOff x="0" y="0"/>
+          <a:chExt cx="0" cy="0"/>
+        </a:xfrm>
+      </p:grpSpPr>
+    </p:spTree>
+  </p:cSld>
+  <p:clrMapOvr>
+    <a:masterClrMapping/>
+  </p:clrMapOvr>
+</p:sld>
+</file>
+
+<file path=ppt/slides/slide26.xml><?xml version="1.0" encoding="utf-8"?>
+<p:sld xmlns:a="http://schemas.openxmlformats.org/drawingml/2006/main" xmlns:r="http://schemas.openxmlformats.org/officeDocument/2006/relationships" xmlns:p="http://schemas.openxmlformats.org/presentationml/2006/main">
+  <p:cSld name="Slide 26">
     <p:bg>
       <p:bgPr>
         <a:blipFill dpi="0" rotWithShape="1">

</xml_diff>